<commit_message>
Enrich summary slide: 3-setting descriptions + aggregated data table
Signed-off-by: XinyuYe-Intel <xinyu.ye@intel.com>
</commit_message>
<xml_diff>
--- a/tpc-xpu-benchs-32-xpu/benchmark_summary.pptx
+++ b/tpc-xpu-benchs-32-xpu/benchmark_summary.pptx
@@ -3096,8 +3096,8 @@
         </p:nvSpPr>
         <p:spPr>
           <a:xfrm>
-            <a:off x="320040" y="164592"/>
-            <a:ext cx="11521440" cy="640080"/>
+            <a:off x="274320" y="109728"/>
+            <a:ext cx="11612880" cy="502920"/>
           </a:xfrm>
           <a:prstGeom prst="rect">
             <a:avLst/>
@@ -3111,7 +3111,7 @@
           <a:lstStyle/>
           <a:p>
             <a:r>
-              <a:rPr sz="2200" b="1">
+              <a:rPr sz="2100" b="1">
                 <a:solidFill>
                   <a:srgbClr val="1A1A1A"/>
                 </a:solidFill>
@@ -3119,21 +3119,103 @@
               <a:t>Tiered Prefix-Cache KV-Offloading on 32x Intel Arc Pro B60 - Baseline vs CPU vs FS</a:t>
             </a:r>
           </a:p>
-          <a:p>
-            <a:r>
-              <a:rPr sz="1100">
+        </p:txBody>
+      </p:sp>
+      <p:sp>
+        <p:nvSpPr>
+          <p:cNvPr id="3" name="TextBox 2"/>
+          <p:cNvSpPr txBox="1"/>
+          <p:nvPr/>
+        </p:nvSpPr>
+        <p:spPr>
+          <a:xfrm>
+            <a:off x="274320" y="603504"/>
+            <a:ext cx="11612880" cy="841248"/>
+          </a:xfrm>
+          <a:prstGeom prst="rect">
+            <a:avLst/>
+          </a:prstGeom>
+          <a:noFill/>
+        </p:spPr>
+        <p:txBody>
+          <a:bodyPr wrap="square">
+            <a:spAutoFit/>
+          </a:bodyPr>
+          <a:lstStyle/>
+          <a:p>
+            <a:pPr>
+              <a:spcAft>
+                <a:spcPts val="100"/>
+              </a:spcAft>
+            </a:pPr>
+            <a:r>
+              <a:rPr sz="1050" b="1">
                 <a:solidFill>
-                  <a:srgbClr val="606060"/>
+                  <a:srgbClr val="7F7F7F"/>
                 </a:solidFill>
               </a:rPr>
-              <a:t>vLLM v0.26.0 - shared-prefix workload, Poisson load ladder - cluster-aggregate throughput / per-request latency</a:t>
+              <a:t>Baseline (no offload):  </a:t>
+            </a:r>
+            <a:r>
+              <a:rPr sz="1050">
+                <a:solidFill>
+                  <a:srgbClr val="333333"/>
+                </a:solidFill>
+              </a:rPr>
+              <a:t>GPU-only prefix cache; evicts &amp; recomputes once the reuse set exceeds VRAM.</a:t>
+            </a:r>
+          </a:p>
+          <a:p>
+            <a:pPr>
+              <a:spcAft>
+                <a:spcPts val="100"/>
+              </a:spcAft>
+            </a:pPr>
+            <a:r>
+              <a:rPr sz="1050" b="1">
+                <a:solidFill>
+                  <a:srgbClr val="1F77B4"/>
+                </a:solidFill>
+              </a:rPr>
+              <a:t>Native CPU offload:  </a:t>
+            </a:r>
+            <a:r>
+              <a:rPr sz="1050">
+                <a:solidFill>
+                  <a:srgbClr val="333333"/>
+                </a:solidFill>
+              </a:rPr>
+              <a:t>KV blocks spill VRAM -&gt; host RAM (OffloadingConnector); tier ~80% of reuse set.</a:t>
+            </a:r>
+          </a:p>
+          <a:p>
+            <a:pPr>
+              <a:spcAft>
+                <a:spcPts val="100"/>
+              </a:spcAft>
+            </a:pPr>
+            <a:r>
+              <a:rPr sz="1050" b="1">
+                <a:solidFill>
+                  <a:srgbClr val="2CA02C"/>
+                </a:solidFill>
+              </a:rPr>
+              <a:t>Native FS offload:  </a:t>
+            </a:r>
+            <a:r>
+              <a:rPr sz="1050">
+                <a:solidFill>
+                  <a:srgbClr val="333333"/>
+                </a:solidFill>
+              </a:rPr>
+              <a:t>KV blocks spill VRAM -&gt; CPU -&gt; node-local NVMe (TieringOffloadingSpec); holds ~full set.</a:t>
             </a:r>
           </a:p>
         </p:txBody>
       </p:sp>
       <p:pic>
         <p:nvPicPr>
-          <p:cNvPr id="3" name="Picture 2" descr="benchmark_summary.png"/>
+          <p:cNvPr id="4" name="Picture 3" descr="benchmark_summary.png"/>
           <p:cNvPicPr>
             <a:picLocks noChangeAspect="1"/>
           </p:cNvPicPr>
@@ -3147,8 +3229,8 @@
         </p:blipFill>
         <p:spPr>
           <a:xfrm>
-            <a:off x="274320" y="914400"/>
-            <a:ext cx="8001000" cy="3670688"/>
+            <a:off x="182880" y="1481328"/>
+            <a:ext cx="7315200" cy="3127680"/>
           </a:xfrm>
           <a:prstGeom prst="rect">
             <a:avLst/>
@@ -3157,14 +3239,14 @@
       </p:pic>
       <p:sp>
         <p:nvSpPr>
-          <p:cNvPr id="4" name="TextBox 3"/>
+          <p:cNvPr id="5" name="TextBox 4"/>
           <p:cNvSpPr txBox="1"/>
           <p:nvPr/>
         </p:nvSpPr>
         <p:spPr>
           <a:xfrm>
-            <a:off x="8412480" y="960120"/>
-            <a:ext cx="3611880" cy="5669280"/>
+            <a:off x="7680960" y="1463040"/>
+            <a:ext cx="4389120" cy="3154680"/>
           </a:xfrm>
           <a:prstGeom prst="rect">
             <a:avLst/>
@@ -3178,7 +3260,7 @@
           <a:lstStyle/>
           <a:p>
             <a:r>
-              <a:rPr sz="1500" b="1">
+              <a:rPr sz="1400" b="1">
                 <a:solidFill>
                   <a:srgbClr val="0F0F0F"/>
                 </a:solidFill>
@@ -3189,71 +3271,56 @@
           <a:p>
             <a:pPr>
               <a:spcBef>
-                <a:spcPts val="600"/>
+                <a:spcPts val="400"/>
               </a:spcBef>
             </a:pPr>
             <a:r>
-              <a:rPr sz="1300" b="1">
+              <a:rPr sz="1100" b="1">
                 <a:solidFill>
                   <a:srgbClr val="153A6B"/>
                 </a:solidFill>
               </a:rPr>
-              <a:t>Qwen3-30B-A3B - FS wins</a:t>
+              <a:t>Qwen3-30B-A3B &amp; Qwen3-32B - FS wins</a:t>
             </a:r>
           </a:p>
           <a:p>
             <a:pPr>
               <a:spcAft>
-                <a:spcPts val="200"/>
+                <a:spcPts val="100"/>
               </a:spcAft>
             </a:pPr>
             <a:r>
-              <a:rPr sz="1050">
+              <a:rPr sz="950">
                 <a:solidFill>
                   <a:srgbClr val="222222"/>
                 </a:solidFill>
               </a:rPr>
-              <a:t>- FS best across the full 2-32 ladder; +30% tok/s and -57% TTFT vs baseline at 32 QPS, ~85% tier-hit.</a:t>
-            </a:r>
-          </a:p>
-          <a:p>
-            <a:pPr>
-              <a:spcBef>
-                <a:spcPts val="600"/>
-              </a:spcBef>
-            </a:pPr>
-            <a:r>
-              <a:rPr sz="1300" b="1">
-                <a:solidFill>
-                  <a:srgbClr val="153A6B"/>
-                </a:solidFill>
-              </a:rPr>
-              <a:t>Qwen3-32B - FS wins</a:t>
+              <a:t>- FS best across the full 2-32 ladder; ~85-87% tier-hit.</a:t>
             </a:r>
           </a:p>
           <a:p>
             <a:pPr>
               <a:spcAft>
-                <a:spcPts val="200"/>
+                <a:spcPts val="100"/>
               </a:spcAft>
             </a:pPr>
             <a:r>
-              <a:rPr sz="1050">
+              <a:rPr sz="950">
                 <a:solidFill>
                   <a:srgbClr val="222222"/>
                 </a:solidFill>
               </a:rPr>
-              <a:t>- FS best across the full 2-32 ladder; +50% tok/s and -46% TTFT vs baseline at 32 QPS, ~87% tier-hit.</a:t>
+              <a:t>- At 32 QPS FS gives +50% tok/s / -46% TTFT (32B) and +30% / -57% (30B) vs baseline.</a:t>
             </a:r>
           </a:p>
           <a:p>
             <a:pPr>
               <a:spcBef>
-                <a:spcPts val="600"/>
+                <a:spcPts val="400"/>
               </a:spcBef>
             </a:pPr>
             <a:r>
-              <a:rPr sz="1300" b="1">
+              <a:rPr sz="1100" b="1">
                 <a:solidFill>
                   <a:srgbClr val="153A6B"/>
                 </a:solidFill>
@@ -3264,41 +3331,41 @@
           <a:p>
             <a:pPr>
               <a:spcAft>
-                <a:spcPts val="200"/>
+                <a:spcPts val="100"/>
               </a:spcAft>
             </a:pPr>
             <a:r>
-              <a:rPr sz="1050">
+              <a:rPr sz="950">
                 <a:solidFill>
                   <a:srgbClr val="222222"/>
                 </a:solidFill>
               </a:rPr>
-              <a:t>- Baseline best at light load (&lt;=2 QPS): offload round-trip not yet amortized.</a:t>
+              <a:t>- Baseline best at light load (&lt;=2 QPS): offload not yet amortized.</a:t>
             </a:r>
           </a:p>
           <a:p>
             <a:pPr>
               <a:spcAft>
-                <a:spcPts val="200"/>
+                <a:spcPts val="100"/>
               </a:spcAft>
             </a:pPr>
             <a:r>
-              <a:rPr sz="1050">
+              <a:rPr sz="950">
                 <a:solidFill>
                   <a:srgbClr val="222222"/>
                 </a:solidFill>
               </a:rPr>
-              <a:t>- FS wins from ~4 QPS up; +29% tok/s and -42% TTFT vs baseline at 6 QPS, ~68% tier-hit.</a:t>
+              <a:t>- FS wins from ~4 QPS; +29% tok/s / -42% TTFT at 6 QPS, ~68% tier-hit.</a:t>
             </a:r>
           </a:p>
           <a:p>
             <a:pPr>
               <a:spcBef>
-                <a:spcPts val="600"/>
+                <a:spcPts val="400"/>
               </a:spcBef>
             </a:pPr>
             <a:r>
-              <a:rPr sz="1300" b="1">
+              <a:rPr sz="1100" b="1">
                 <a:solidFill>
                   <a:srgbClr val="153A6B"/>
                 </a:solidFill>
@@ -3309,11 +3376,11 @@
           <a:p>
             <a:pPr>
               <a:spcAft>
-                <a:spcPts val="200"/>
+                <a:spcPts val="100"/>
               </a:spcAft>
             </a:pPr>
             <a:r>
-              <a:rPr sz="1050">
+              <a:rPr sz="950">
                 <a:solidFill>
                   <a:srgbClr val="186018"/>
                 </a:solidFill>
@@ -3324,20 +3391,1574 @@
           <a:p>
             <a:pPr>
               <a:spcAft>
-                <a:spcPts val="200"/>
+                <a:spcPts val="100"/>
               </a:spcAft>
             </a:pPr>
             <a:r>
-              <a:rPr sz="1050">
+              <a:rPr sz="950">
                 <a:solidFill>
                   <a:srgbClr val="222222"/>
                 </a:solidFill>
               </a:rPr>
-              <a:t>- Benefit scales with offered load and prefix-reuse working set; PCIe-bound (no Xe-Link), so it pays off once recompute pressure exceeds transfer cost.</a:t>
-            </a:r>
-          </a:p>
-        </p:txBody>
-      </p:sp>
+              <a:t>- PCIe-bound (no Xe-Link) - pays off once recompute pressure exceeds transfer cost.</a:t>
+            </a:r>
+          </a:p>
+        </p:txBody>
+      </p:sp>
+      <p:sp>
+        <p:nvSpPr>
+          <p:cNvPr id="6" name="TextBox 5"/>
+          <p:cNvSpPr txBox="1"/>
+          <p:nvPr/>
+        </p:nvSpPr>
+        <p:spPr>
+          <a:xfrm>
+            <a:off x="274320" y="4645152"/>
+            <a:ext cx="11612880" cy="274320"/>
+          </a:xfrm>
+          <a:prstGeom prst="rect">
+            <a:avLst/>
+          </a:prstGeom>
+          <a:noFill/>
+        </p:spPr>
+        <p:txBody>
+          <a:bodyPr wrap="none">
+            <a:spAutoFit/>
+          </a:bodyPr>
+          <a:lstStyle/>
+          <a:p>
+            <a:r>
+              <a:rPr sz="1100" b="1">
+                <a:solidFill>
+                  <a:srgbClr val="0F0F0F"/>
+                </a:solidFill>
+              </a:rPr>
+              <a:t>Aggregated results at each model's peak sustained (failure-free) QPS</a:t>
+            </a:r>
+          </a:p>
+        </p:txBody>
+      </p:sp>
+      <p:graphicFrame>
+        <p:nvGraphicFramePr>
+          <p:cNvPr id="7" name="Table 6"/>
+          <p:cNvGraphicFramePr>
+            <a:graphicFrameLocks noGrp="1"/>
+          </p:cNvGraphicFramePr>
+          <p:nvPr/>
+        </p:nvGraphicFramePr>
+        <p:xfrm>
+          <a:off x="274320" y="4937760"/>
+          <a:ext cx="11640310" cy="1737360"/>
+        </p:xfrm>
+        <a:graphic>
+          <a:graphicData uri="http://schemas.openxmlformats.org/drawingml/2006/table">
+            <a:tbl>
+              <a:tblPr firstRow="1" bandRow="1">
+                <a:tableStyleId>{5C22544A-7EE6-4342-B048-85BDC9FD1C3A}</a:tableStyleId>
+              </a:tblPr>
+              <a:tblGrid>
+                <a:gridCol w="2011680"/>
+                <a:gridCol w="2286000"/>
+                <a:gridCol w="1468526"/>
+                <a:gridCol w="1468526"/>
+                <a:gridCol w="1468526"/>
+                <a:gridCol w="1468526"/>
+                <a:gridCol w="1468526"/>
+              </a:tblGrid>
+              <a:tr h="173736">
+                <a:tc>
+                  <a:txBody>
+                    <a:bodyPr/>
+                    <a:lstStyle/>
+                    <a:p>
+                      <a:r>
+                        <a:rPr sz="900" b="1">
+                          <a:solidFill>
+                            <a:srgbClr val="FFFFFF"/>
+                          </a:solidFill>
+                        </a:rPr>
+                        <a:t>Model</a:t>
+                      </a:r>
+                    </a:p>
+                  </a:txBody>
+                  <a:tcPr marT="12700" marB="12700" marL="50800" marR="50800" anchor="ctr">
+                    <a:solidFill>
+                      <a:srgbClr val="2F4B6E"/>
+                    </a:solidFill>
+                  </a:tcPr>
+                </a:tc>
+                <a:tc>
+                  <a:txBody>
+                    <a:bodyPr/>
+                    <a:lstStyle/>
+                    <a:p>
+                      <a:r>
+                        <a:rPr sz="900" b="1">
+                          <a:solidFill>
+                            <a:srgbClr val="FFFFFF"/>
+                          </a:solidFill>
+                        </a:rPr>
+                        <a:t>Config</a:t>
+                      </a:r>
+                    </a:p>
+                  </a:txBody>
+                  <a:tcPr marT="12700" marB="12700" marL="50800" marR="50800" anchor="ctr">
+                    <a:solidFill>
+                      <a:srgbClr val="2F4B6E"/>
+                    </a:solidFill>
+                  </a:tcPr>
+                </a:tc>
+                <a:tc>
+                  <a:txBody>
+                    <a:bodyPr/>
+                    <a:lstStyle/>
+                    <a:p>
+                      <a:r>
+                        <a:rPr sz="900" b="1">
+                          <a:solidFill>
+                            <a:srgbClr val="FFFFFF"/>
+                          </a:solidFill>
+                        </a:rPr>
+                        <a:t>Peak QPS</a:t>
+                      </a:r>
+                    </a:p>
+                  </a:txBody>
+                  <a:tcPr marT="12700" marB="12700" marL="50800" marR="50800" anchor="ctr">
+                    <a:solidFill>
+                      <a:srgbClr val="2F4B6E"/>
+                    </a:solidFill>
+                  </a:tcPr>
+                </a:tc>
+                <a:tc>
+                  <a:txBody>
+                    <a:bodyPr/>
+                    <a:lstStyle/>
+                    <a:p>
+                      <a:r>
+                        <a:rPr sz="900" b="1">
+                          <a:solidFill>
+                            <a:srgbClr val="FFFFFF"/>
+                          </a:solidFill>
+                        </a:rPr>
+                        <a:t>Out tok/s</a:t>
+                      </a:r>
+                    </a:p>
+                  </a:txBody>
+                  <a:tcPr marT="12700" marB="12700" marL="50800" marR="50800" anchor="ctr">
+                    <a:solidFill>
+                      <a:srgbClr val="2F4B6E"/>
+                    </a:solidFill>
+                  </a:tcPr>
+                </a:tc>
+                <a:tc>
+                  <a:txBody>
+                    <a:bodyPr/>
+                    <a:lstStyle/>
+                    <a:p>
+                      <a:r>
+                        <a:rPr sz="900" b="1">
+                          <a:solidFill>
+                            <a:srgbClr val="FFFFFF"/>
+                          </a:solidFill>
+                        </a:rPr>
+                        <a:t>TTFT mean (s)</a:t>
+                      </a:r>
+                    </a:p>
+                  </a:txBody>
+                  <a:tcPr marT="12700" marB="12700" marL="50800" marR="50800" anchor="ctr">
+                    <a:solidFill>
+                      <a:srgbClr val="2F4B6E"/>
+                    </a:solidFill>
+                  </a:tcPr>
+                </a:tc>
+                <a:tc>
+                  <a:txBody>
+                    <a:bodyPr/>
+                    <a:lstStyle/>
+                    <a:p>
+                      <a:r>
+                        <a:rPr sz="900" b="1">
+                          <a:solidFill>
+                            <a:srgbClr val="FFFFFF"/>
+                          </a:solidFill>
+                        </a:rPr>
+                        <a:t>E2E p99 (s)</a:t>
+                      </a:r>
+                    </a:p>
+                  </a:txBody>
+                  <a:tcPr marT="12700" marB="12700" marL="50800" marR="50800" anchor="ctr">
+                    <a:solidFill>
+                      <a:srgbClr val="2F4B6E"/>
+                    </a:solidFill>
+                  </a:tcPr>
+                </a:tc>
+                <a:tc>
+                  <a:txBody>
+                    <a:bodyPr/>
+                    <a:lstStyle/>
+                    <a:p>
+                      <a:r>
+                        <a:rPr sz="900" b="1">
+                          <a:solidFill>
+                            <a:srgbClr val="FFFFFF"/>
+                          </a:solidFill>
+                        </a:rPr>
+                        <a:t>Tier-hit %</a:t>
+                      </a:r>
+                    </a:p>
+                  </a:txBody>
+                  <a:tcPr marT="12700" marB="12700" marL="50800" marR="50800" anchor="ctr">
+                    <a:solidFill>
+                      <a:srgbClr val="2F4B6E"/>
+                    </a:solidFill>
+                  </a:tcPr>
+                </a:tc>
+              </a:tr>
+              <a:tr h="173736">
+                <a:tc>
+                  <a:txBody>
+                    <a:bodyPr/>
+                    <a:lstStyle/>
+                    <a:p>
+                      <a:r>
+                        <a:rPr sz="900">
+                          <a:solidFill>
+                            <a:srgbClr val="202020"/>
+                          </a:solidFill>
+                        </a:rPr>
+                        <a:t>Llama-3 70B</a:t>
+                      </a:r>
+                    </a:p>
+                  </a:txBody>
+                  <a:tcPr marT="12700" marB="12700" marL="50800" marR="50800" anchor="ctr">
+                    <a:solidFill>
+                      <a:srgbClr val="FFFFFF"/>
+                    </a:solidFill>
+                  </a:tcPr>
+                </a:tc>
+                <a:tc>
+                  <a:txBody>
+                    <a:bodyPr/>
+                    <a:lstStyle/>
+                    <a:p>
+                      <a:r>
+                        <a:rPr sz="900" b="1">
+                          <a:solidFill>
+                            <a:srgbClr val="7F7F7F"/>
+                          </a:solidFill>
+                        </a:rPr>
+                        <a:t>Baseline</a:t>
+                      </a:r>
+                    </a:p>
+                  </a:txBody>
+                  <a:tcPr marT="12700" marB="12700" marL="50800" marR="50800" anchor="ctr">
+                    <a:solidFill>
+                      <a:srgbClr val="FFFFFF"/>
+                    </a:solidFill>
+                  </a:tcPr>
+                </a:tc>
+                <a:tc>
+                  <a:txBody>
+                    <a:bodyPr/>
+                    <a:lstStyle/>
+                    <a:p>
+                      <a:r>
+                        <a:rPr sz="900">
+                          <a:solidFill>
+                            <a:srgbClr val="202020"/>
+                          </a:solidFill>
+                        </a:rPr>
+                        <a:t>6</a:t>
+                      </a:r>
+                    </a:p>
+                  </a:txBody>
+                  <a:tcPr marT="12700" marB="12700" marL="50800" marR="50800" anchor="ctr">
+                    <a:solidFill>
+                      <a:srgbClr val="FFFFFF"/>
+                    </a:solidFill>
+                  </a:tcPr>
+                </a:tc>
+                <a:tc>
+                  <a:txBody>
+                    <a:bodyPr/>
+                    <a:lstStyle/>
+                    <a:p>
+                      <a:r>
+                        <a:rPr sz="900">
+                          <a:solidFill>
+                            <a:srgbClr val="202020"/>
+                          </a:solidFill>
+                        </a:rPr>
+                        <a:t>305</a:t>
+                      </a:r>
+                    </a:p>
+                  </a:txBody>
+                  <a:tcPr marT="12700" marB="12700" marL="50800" marR="50800" anchor="ctr">
+                    <a:solidFill>
+                      <a:srgbClr val="FFFFFF"/>
+                    </a:solidFill>
+                  </a:tcPr>
+                </a:tc>
+                <a:tc>
+                  <a:txBody>
+                    <a:bodyPr/>
+                    <a:lstStyle/>
+                    <a:p>
+                      <a:r>
+                        <a:rPr sz="900">
+                          <a:solidFill>
+                            <a:srgbClr val="202020"/>
+                          </a:solidFill>
+                        </a:rPr>
+                        <a:t>100.38</a:t>
+                      </a:r>
+                    </a:p>
+                  </a:txBody>
+                  <a:tcPr marT="12700" marB="12700" marL="50800" marR="50800" anchor="ctr">
+                    <a:solidFill>
+                      <a:srgbClr val="FFFFFF"/>
+                    </a:solidFill>
+                  </a:tcPr>
+                </a:tc>
+                <a:tc>
+                  <a:txBody>
+                    <a:bodyPr/>
+                    <a:lstStyle/>
+                    <a:p>
+                      <a:r>
+                        <a:rPr sz="900">
+                          <a:solidFill>
+                            <a:srgbClr val="202020"/>
+                          </a:solidFill>
+                        </a:rPr>
+                        <a:t>238.7</a:t>
+                      </a:r>
+                    </a:p>
+                  </a:txBody>
+                  <a:tcPr marT="12700" marB="12700" marL="50800" marR="50800" anchor="ctr">
+                    <a:solidFill>
+                      <a:srgbClr val="FFFFFF"/>
+                    </a:solidFill>
+                  </a:tcPr>
+                </a:tc>
+                <a:tc>
+                  <a:txBody>
+                    <a:bodyPr/>
+                    <a:lstStyle/>
+                    <a:p>
+                      <a:r>
+                        <a:rPr sz="900">
+                          <a:solidFill>
+                            <a:srgbClr val="202020"/>
+                          </a:solidFill>
+                        </a:rPr>
+                        <a:t>-</a:t>
+                      </a:r>
+                    </a:p>
+                  </a:txBody>
+                  <a:tcPr marT="12700" marB="12700" marL="50800" marR="50800" anchor="ctr">
+                    <a:solidFill>
+                      <a:srgbClr val="FFFFFF"/>
+                    </a:solidFill>
+                  </a:tcPr>
+                </a:tc>
+              </a:tr>
+              <a:tr h="173736">
+                <a:tc>
+                  <a:txBody>
+                    <a:bodyPr/>
+                    <a:lstStyle/>
+                    <a:p>
+                      <a:r>
+                        <a:rPr sz="900">
+                          <a:solidFill>
+                            <a:srgbClr val="202020"/>
+                          </a:solidFill>
+                        </a:rPr>
+                        <a:t/>
+                      </a:r>
+                    </a:p>
+                  </a:txBody>
+                  <a:tcPr marT="12700" marB="12700" marL="50800" marR="50800" anchor="ctr">
+                    <a:solidFill>
+                      <a:srgbClr val="FFFFFF"/>
+                    </a:solidFill>
+                  </a:tcPr>
+                </a:tc>
+                <a:tc>
+                  <a:txBody>
+                    <a:bodyPr/>
+                    <a:lstStyle/>
+                    <a:p>
+                      <a:r>
+                        <a:rPr sz="900" b="1">
+                          <a:solidFill>
+                            <a:srgbClr val="1F77B4"/>
+                          </a:solidFill>
+                        </a:rPr>
+                        <a:t>Native CPU offload</a:t>
+                      </a:r>
+                    </a:p>
+                  </a:txBody>
+                  <a:tcPr marT="12700" marB="12700" marL="50800" marR="50800" anchor="ctr">
+                    <a:solidFill>
+                      <a:srgbClr val="FFFFFF"/>
+                    </a:solidFill>
+                  </a:tcPr>
+                </a:tc>
+                <a:tc>
+                  <a:txBody>
+                    <a:bodyPr/>
+                    <a:lstStyle/>
+                    <a:p>
+                      <a:r>
+                        <a:rPr sz="900">
+                          <a:solidFill>
+                            <a:srgbClr val="202020"/>
+                          </a:solidFill>
+                        </a:rPr>
+                        <a:t>6</a:t>
+                      </a:r>
+                    </a:p>
+                  </a:txBody>
+                  <a:tcPr marT="12700" marB="12700" marL="50800" marR="50800" anchor="ctr">
+                    <a:solidFill>
+                      <a:srgbClr val="FFFFFF"/>
+                    </a:solidFill>
+                  </a:tcPr>
+                </a:tc>
+                <a:tc>
+                  <a:txBody>
+                    <a:bodyPr/>
+                    <a:lstStyle/>
+                    <a:p>
+                      <a:r>
+                        <a:rPr sz="900">
+                          <a:solidFill>
+                            <a:srgbClr val="202020"/>
+                          </a:solidFill>
+                        </a:rPr>
+                        <a:t>340</a:t>
+                      </a:r>
+                    </a:p>
+                  </a:txBody>
+                  <a:tcPr marT="12700" marB="12700" marL="50800" marR="50800" anchor="ctr">
+                    <a:solidFill>
+                      <a:srgbClr val="FFFFFF"/>
+                    </a:solidFill>
+                  </a:tcPr>
+                </a:tc>
+                <a:tc>
+                  <a:txBody>
+                    <a:bodyPr/>
+                    <a:lstStyle/>
+                    <a:p>
+                      <a:r>
+                        <a:rPr sz="900">
+                          <a:solidFill>
+                            <a:srgbClr val="202020"/>
+                          </a:solidFill>
+                        </a:rPr>
+                        <a:t>90.69</a:t>
+                      </a:r>
+                    </a:p>
+                  </a:txBody>
+                  <a:tcPr marT="12700" marB="12700" marL="50800" marR="50800" anchor="ctr">
+                    <a:solidFill>
+                      <a:srgbClr val="FFFFFF"/>
+                    </a:solidFill>
+                  </a:tcPr>
+                </a:tc>
+                <a:tc>
+                  <a:txBody>
+                    <a:bodyPr/>
+                    <a:lstStyle/>
+                    <a:p>
+                      <a:r>
+                        <a:rPr sz="900">
+                          <a:solidFill>
+                            <a:srgbClr val="202020"/>
+                          </a:solidFill>
+                        </a:rPr>
+                        <a:t>216.0</a:t>
+                      </a:r>
+                    </a:p>
+                  </a:txBody>
+                  <a:tcPr marT="12700" marB="12700" marL="50800" marR="50800" anchor="ctr">
+                    <a:solidFill>
+                      <a:srgbClr val="FFFFFF"/>
+                    </a:solidFill>
+                  </a:tcPr>
+                </a:tc>
+                <a:tc>
+                  <a:txBody>
+                    <a:bodyPr/>
+                    <a:lstStyle/>
+                    <a:p>
+                      <a:r>
+                        <a:rPr sz="900">
+                          <a:solidFill>
+                            <a:srgbClr val="202020"/>
+                          </a:solidFill>
+                        </a:rPr>
+                        <a:t>43</a:t>
+                      </a:r>
+                    </a:p>
+                  </a:txBody>
+                  <a:tcPr marT="12700" marB="12700" marL="50800" marR="50800" anchor="ctr">
+                    <a:solidFill>
+                      <a:srgbClr val="FFFFFF"/>
+                    </a:solidFill>
+                  </a:tcPr>
+                </a:tc>
+              </a:tr>
+              <a:tr h="173736">
+                <a:tc>
+                  <a:txBody>
+                    <a:bodyPr/>
+                    <a:lstStyle/>
+                    <a:p>
+                      <a:r>
+                        <a:rPr sz="900">
+                          <a:solidFill>
+                            <a:srgbClr val="202020"/>
+                          </a:solidFill>
+                        </a:rPr>
+                        <a:t/>
+                      </a:r>
+                    </a:p>
+                  </a:txBody>
+                  <a:tcPr marT="12700" marB="12700" marL="50800" marR="50800" anchor="ctr">
+                    <a:solidFill>
+                      <a:srgbClr val="FFFFFF"/>
+                    </a:solidFill>
+                  </a:tcPr>
+                </a:tc>
+                <a:tc>
+                  <a:txBody>
+                    <a:bodyPr/>
+                    <a:lstStyle/>
+                    <a:p>
+                      <a:r>
+                        <a:rPr sz="900" b="1">
+                          <a:solidFill>
+                            <a:srgbClr val="2CA02C"/>
+                          </a:solidFill>
+                        </a:rPr>
+                        <a:t>Native FS offload</a:t>
+                      </a:r>
+                    </a:p>
+                  </a:txBody>
+                  <a:tcPr marT="12700" marB="12700" marL="50800" marR="50800" anchor="ctr">
+                    <a:solidFill>
+                      <a:srgbClr val="FFFFFF"/>
+                    </a:solidFill>
+                  </a:tcPr>
+                </a:tc>
+                <a:tc>
+                  <a:txBody>
+                    <a:bodyPr/>
+                    <a:lstStyle/>
+                    <a:p>
+                      <a:r>
+                        <a:rPr sz="900">
+                          <a:solidFill>
+                            <a:srgbClr val="202020"/>
+                          </a:solidFill>
+                        </a:rPr>
+                        <a:t>6</a:t>
+                      </a:r>
+                    </a:p>
+                  </a:txBody>
+                  <a:tcPr marT="12700" marB="12700" marL="50800" marR="50800" anchor="ctr">
+                    <a:solidFill>
+                      <a:srgbClr val="FFFFFF"/>
+                    </a:solidFill>
+                  </a:tcPr>
+                </a:tc>
+                <a:tc>
+                  <a:txBody>
+                    <a:bodyPr/>
+                    <a:lstStyle/>
+                    <a:p>
+                      <a:r>
+                        <a:rPr sz="900">
+                          <a:solidFill>
+                            <a:srgbClr val="202020"/>
+                          </a:solidFill>
+                        </a:rPr>
+                        <a:t>393</a:t>
+                      </a:r>
+                    </a:p>
+                  </a:txBody>
+                  <a:tcPr marT="12700" marB="12700" marL="50800" marR="50800" anchor="ctr">
+                    <a:solidFill>
+                      <a:srgbClr val="FFFFFF"/>
+                    </a:solidFill>
+                  </a:tcPr>
+                </a:tc>
+                <a:tc>
+                  <a:txBody>
+                    <a:bodyPr/>
+                    <a:lstStyle/>
+                    <a:p>
+                      <a:r>
+                        <a:rPr sz="900">
+                          <a:solidFill>
+                            <a:srgbClr val="202020"/>
+                          </a:solidFill>
+                        </a:rPr>
+                        <a:t>58.52</a:t>
+                      </a:r>
+                    </a:p>
+                  </a:txBody>
+                  <a:tcPr marT="12700" marB="12700" marL="50800" marR="50800" anchor="ctr">
+                    <a:solidFill>
+                      <a:srgbClr val="FFFFFF"/>
+                    </a:solidFill>
+                  </a:tcPr>
+                </a:tc>
+                <a:tc>
+                  <a:txBody>
+                    <a:bodyPr/>
+                    <a:lstStyle/>
+                    <a:p>
+                      <a:r>
+                        <a:rPr sz="900">
+                          <a:solidFill>
+                            <a:srgbClr val="202020"/>
+                          </a:solidFill>
+                        </a:rPr>
+                        <a:t>183.2</a:t>
+                      </a:r>
+                    </a:p>
+                  </a:txBody>
+                  <a:tcPr marT="12700" marB="12700" marL="50800" marR="50800" anchor="ctr">
+                    <a:solidFill>
+                      <a:srgbClr val="FFFFFF"/>
+                    </a:solidFill>
+                  </a:tcPr>
+                </a:tc>
+                <a:tc>
+                  <a:txBody>
+                    <a:bodyPr/>
+                    <a:lstStyle/>
+                    <a:p>
+                      <a:r>
+                        <a:rPr sz="900">
+                          <a:solidFill>
+                            <a:srgbClr val="202020"/>
+                          </a:solidFill>
+                        </a:rPr>
+                        <a:t>68</a:t>
+                      </a:r>
+                    </a:p>
+                  </a:txBody>
+                  <a:tcPr marT="12700" marB="12700" marL="50800" marR="50800" anchor="ctr">
+                    <a:solidFill>
+                      <a:srgbClr val="FFFFFF"/>
+                    </a:solidFill>
+                  </a:tcPr>
+                </a:tc>
+              </a:tr>
+              <a:tr h="173736">
+                <a:tc>
+                  <a:txBody>
+                    <a:bodyPr/>
+                    <a:lstStyle/>
+                    <a:p>
+                      <a:r>
+                        <a:rPr sz="900">
+                          <a:solidFill>
+                            <a:srgbClr val="202020"/>
+                          </a:solidFill>
+                        </a:rPr>
+                        <a:t>Qwen3-30B-A3B</a:t>
+                      </a:r>
+                    </a:p>
+                  </a:txBody>
+                  <a:tcPr marT="12700" marB="12700" marL="50800" marR="50800" anchor="ctr">
+                    <a:solidFill>
+                      <a:srgbClr val="F2F5F9"/>
+                    </a:solidFill>
+                  </a:tcPr>
+                </a:tc>
+                <a:tc>
+                  <a:txBody>
+                    <a:bodyPr/>
+                    <a:lstStyle/>
+                    <a:p>
+                      <a:r>
+                        <a:rPr sz="900" b="1">
+                          <a:solidFill>
+                            <a:srgbClr val="7F7F7F"/>
+                          </a:solidFill>
+                        </a:rPr>
+                        <a:t>Baseline</a:t>
+                      </a:r>
+                    </a:p>
+                  </a:txBody>
+                  <a:tcPr marT="12700" marB="12700" marL="50800" marR="50800" anchor="ctr">
+                    <a:solidFill>
+                      <a:srgbClr val="F2F5F9"/>
+                    </a:solidFill>
+                  </a:tcPr>
+                </a:tc>
+                <a:tc>
+                  <a:txBody>
+                    <a:bodyPr/>
+                    <a:lstStyle/>
+                    <a:p>
+                      <a:r>
+                        <a:rPr sz="900">
+                          <a:solidFill>
+                            <a:srgbClr val="202020"/>
+                          </a:solidFill>
+                        </a:rPr>
+                        <a:t>32</a:t>
+                      </a:r>
+                    </a:p>
+                  </a:txBody>
+                  <a:tcPr marT="12700" marB="12700" marL="50800" marR="50800" anchor="ctr">
+                    <a:solidFill>
+                      <a:srgbClr val="F2F5F9"/>
+                    </a:solidFill>
+                  </a:tcPr>
+                </a:tc>
+                <a:tc>
+                  <a:txBody>
+                    <a:bodyPr/>
+                    <a:lstStyle/>
+                    <a:p>
+                      <a:r>
+                        <a:rPr sz="900">
+                          <a:solidFill>
+                            <a:srgbClr val="202020"/>
+                          </a:solidFill>
+                        </a:rPr>
+                        <a:t>1520</a:t>
+                      </a:r>
+                    </a:p>
+                  </a:txBody>
+                  <a:tcPr marT="12700" marB="12700" marL="50800" marR="50800" anchor="ctr">
+                    <a:solidFill>
+                      <a:srgbClr val="F2F5F9"/>
+                    </a:solidFill>
+                  </a:tcPr>
+                </a:tc>
+                <a:tc>
+                  <a:txBody>
+                    <a:bodyPr/>
+                    <a:lstStyle/>
+                    <a:p>
+                      <a:r>
+                        <a:rPr sz="900">
+                          <a:solidFill>
+                            <a:srgbClr val="202020"/>
+                          </a:solidFill>
+                        </a:rPr>
+                        <a:t>186.78</a:t>
+                      </a:r>
+                    </a:p>
+                  </a:txBody>
+                  <a:tcPr marT="12700" marB="12700" marL="50800" marR="50800" anchor="ctr">
+                    <a:solidFill>
+                      <a:srgbClr val="F2F5F9"/>
+                    </a:solidFill>
+                  </a:tcPr>
+                </a:tc>
+                <a:tc>
+                  <a:txBody>
+                    <a:bodyPr/>
+                    <a:lstStyle/>
+                    <a:p>
+                      <a:r>
+                        <a:rPr sz="900">
+                          <a:solidFill>
+                            <a:srgbClr val="202020"/>
+                          </a:solidFill>
+                        </a:rPr>
+                        <a:t>401.5</a:t>
+                      </a:r>
+                    </a:p>
+                  </a:txBody>
+                  <a:tcPr marT="12700" marB="12700" marL="50800" marR="50800" anchor="ctr">
+                    <a:solidFill>
+                      <a:srgbClr val="F2F5F9"/>
+                    </a:solidFill>
+                  </a:tcPr>
+                </a:tc>
+                <a:tc>
+                  <a:txBody>
+                    <a:bodyPr/>
+                    <a:lstStyle/>
+                    <a:p>
+                      <a:r>
+                        <a:rPr sz="900">
+                          <a:solidFill>
+                            <a:srgbClr val="202020"/>
+                          </a:solidFill>
+                        </a:rPr>
+                        <a:t>-</a:t>
+                      </a:r>
+                    </a:p>
+                  </a:txBody>
+                  <a:tcPr marT="12700" marB="12700" marL="50800" marR="50800" anchor="ctr">
+                    <a:solidFill>
+                      <a:srgbClr val="F2F5F9"/>
+                    </a:solidFill>
+                  </a:tcPr>
+                </a:tc>
+              </a:tr>
+              <a:tr h="173736">
+                <a:tc>
+                  <a:txBody>
+                    <a:bodyPr/>
+                    <a:lstStyle/>
+                    <a:p>
+                      <a:r>
+                        <a:rPr sz="900">
+                          <a:solidFill>
+                            <a:srgbClr val="202020"/>
+                          </a:solidFill>
+                        </a:rPr>
+                        <a:t/>
+                      </a:r>
+                    </a:p>
+                  </a:txBody>
+                  <a:tcPr marT="12700" marB="12700" marL="50800" marR="50800" anchor="ctr">
+                    <a:solidFill>
+                      <a:srgbClr val="F2F5F9"/>
+                    </a:solidFill>
+                  </a:tcPr>
+                </a:tc>
+                <a:tc>
+                  <a:txBody>
+                    <a:bodyPr/>
+                    <a:lstStyle/>
+                    <a:p>
+                      <a:r>
+                        <a:rPr sz="900" b="1">
+                          <a:solidFill>
+                            <a:srgbClr val="1F77B4"/>
+                          </a:solidFill>
+                        </a:rPr>
+                        <a:t>Native CPU offload</a:t>
+                      </a:r>
+                    </a:p>
+                  </a:txBody>
+                  <a:tcPr marT="12700" marB="12700" marL="50800" marR="50800" anchor="ctr">
+                    <a:solidFill>
+                      <a:srgbClr val="F2F5F9"/>
+                    </a:solidFill>
+                  </a:tcPr>
+                </a:tc>
+                <a:tc>
+                  <a:txBody>
+                    <a:bodyPr/>
+                    <a:lstStyle/>
+                    <a:p>
+                      <a:r>
+                        <a:rPr sz="900">
+                          <a:solidFill>
+                            <a:srgbClr val="202020"/>
+                          </a:solidFill>
+                        </a:rPr>
+                        <a:t>32</a:t>
+                      </a:r>
+                    </a:p>
+                  </a:txBody>
+                  <a:tcPr marT="12700" marB="12700" marL="50800" marR="50800" anchor="ctr">
+                    <a:solidFill>
+                      <a:srgbClr val="F2F5F9"/>
+                    </a:solidFill>
+                  </a:tcPr>
+                </a:tc>
+                <a:tc>
+                  <a:txBody>
+                    <a:bodyPr/>
+                    <a:lstStyle/>
+                    <a:p>
+                      <a:r>
+                        <a:rPr sz="900">
+                          <a:solidFill>
+                            <a:srgbClr val="202020"/>
+                          </a:solidFill>
+                        </a:rPr>
+                        <a:t>1229</a:t>
+                      </a:r>
+                    </a:p>
+                  </a:txBody>
+                  <a:tcPr marT="12700" marB="12700" marL="50800" marR="50800" anchor="ctr">
+                    <a:solidFill>
+                      <a:srgbClr val="F2F5F9"/>
+                    </a:solidFill>
+                  </a:tcPr>
+                </a:tc>
+                <a:tc>
+                  <a:txBody>
+                    <a:bodyPr/>
+                    <a:lstStyle/>
+                    <a:p>
+                      <a:r>
+                        <a:rPr sz="900">
+                          <a:solidFill>
+                            <a:srgbClr val="202020"/>
+                          </a:solidFill>
+                        </a:rPr>
+                        <a:t>161.45</a:t>
+                      </a:r>
+                    </a:p>
+                  </a:txBody>
+                  <a:tcPr marT="12700" marB="12700" marL="50800" marR="50800" anchor="ctr">
+                    <a:solidFill>
+                      <a:srgbClr val="F2F5F9"/>
+                    </a:solidFill>
+                  </a:tcPr>
+                </a:tc>
+                <a:tc>
+                  <a:txBody>
+                    <a:bodyPr/>
+                    <a:lstStyle/>
+                    <a:p>
+                      <a:r>
+                        <a:rPr sz="900">
+                          <a:solidFill>
+                            <a:srgbClr val="202020"/>
+                          </a:solidFill>
+                        </a:rPr>
+                        <a:t>357.9</a:t>
+                      </a:r>
+                    </a:p>
+                  </a:txBody>
+                  <a:tcPr marT="12700" marB="12700" marL="50800" marR="50800" anchor="ctr">
+                    <a:solidFill>
+                      <a:srgbClr val="F2F5F9"/>
+                    </a:solidFill>
+                  </a:tcPr>
+                </a:tc>
+                <a:tc>
+                  <a:txBody>
+                    <a:bodyPr/>
+                    <a:lstStyle/>
+                    <a:p>
+                      <a:r>
+                        <a:rPr sz="900">
+                          <a:solidFill>
+                            <a:srgbClr val="202020"/>
+                          </a:solidFill>
+                        </a:rPr>
+                        <a:t>38</a:t>
+                      </a:r>
+                    </a:p>
+                  </a:txBody>
+                  <a:tcPr marT="12700" marB="12700" marL="50800" marR="50800" anchor="ctr">
+                    <a:solidFill>
+                      <a:srgbClr val="F2F5F9"/>
+                    </a:solidFill>
+                  </a:tcPr>
+                </a:tc>
+              </a:tr>
+              <a:tr h="173736">
+                <a:tc>
+                  <a:txBody>
+                    <a:bodyPr/>
+                    <a:lstStyle/>
+                    <a:p>
+                      <a:r>
+                        <a:rPr sz="900">
+                          <a:solidFill>
+                            <a:srgbClr val="202020"/>
+                          </a:solidFill>
+                        </a:rPr>
+                        <a:t/>
+                      </a:r>
+                    </a:p>
+                  </a:txBody>
+                  <a:tcPr marT="12700" marB="12700" marL="50800" marR="50800" anchor="ctr">
+                    <a:solidFill>
+                      <a:srgbClr val="F2F5F9"/>
+                    </a:solidFill>
+                  </a:tcPr>
+                </a:tc>
+                <a:tc>
+                  <a:txBody>
+                    <a:bodyPr/>
+                    <a:lstStyle/>
+                    <a:p>
+                      <a:r>
+                        <a:rPr sz="900" b="1">
+                          <a:solidFill>
+                            <a:srgbClr val="2CA02C"/>
+                          </a:solidFill>
+                        </a:rPr>
+                        <a:t>Native FS offload</a:t>
+                      </a:r>
+                    </a:p>
+                  </a:txBody>
+                  <a:tcPr marT="12700" marB="12700" marL="50800" marR="50800" anchor="ctr">
+                    <a:solidFill>
+                      <a:srgbClr val="F2F5F9"/>
+                    </a:solidFill>
+                  </a:tcPr>
+                </a:tc>
+                <a:tc>
+                  <a:txBody>
+                    <a:bodyPr/>
+                    <a:lstStyle/>
+                    <a:p>
+                      <a:r>
+                        <a:rPr sz="900">
+                          <a:solidFill>
+                            <a:srgbClr val="202020"/>
+                          </a:solidFill>
+                        </a:rPr>
+                        <a:t>32</a:t>
+                      </a:r>
+                    </a:p>
+                  </a:txBody>
+                  <a:tcPr marT="12700" marB="12700" marL="50800" marR="50800" anchor="ctr">
+                    <a:solidFill>
+                      <a:srgbClr val="F2F5F9"/>
+                    </a:solidFill>
+                  </a:tcPr>
+                </a:tc>
+                <a:tc>
+                  <a:txBody>
+                    <a:bodyPr/>
+                    <a:lstStyle/>
+                    <a:p>
+                      <a:r>
+                        <a:rPr sz="900">
+                          <a:solidFill>
+                            <a:srgbClr val="202020"/>
+                          </a:solidFill>
+                        </a:rPr>
+                        <a:t>1969</a:t>
+                      </a:r>
+                    </a:p>
+                  </a:txBody>
+                  <a:tcPr marT="12700" marB="12700" marL="50800" marR="50800" anchor="ctr">
+                    <a:solidFill>
+                      <a:srgbClr val="F2F5F9"/>
+                    </a:solidFill>
+                  </a:tcPr>
+                </a:tc>
+                <a:tc>
+                  <a:txBody>
+                    <a:bodyPr/>
+                    <a:lstStyle/>
+                    <a:p>
+                      <a:r>
+                        <a:rPr sz="900">
+                          <a:solidFill>
+                            <a:srgbClr val="202020"/>
+                          </a:solidFill>
+                        </a:rPr>
+                        <a:t>81.18</a:t>
+                      </a:r>
+                    </a:p>
+                  </a:txBody>
+                  <a:tcPr marT="12700" marB="12700" marL="50800" marR="50800" anchor="ctr">
+                    <a:solidFill>
+                      <a:srgbClr val="F2F5F9"/>
+                    </a:solidFill>
+                  </a:tcPr>
+                </a:tc>
+                <a:tc>
+                  <a:txBody>
+                    <a:bodyPr/>
+                    <a:lstStyle/>
+                    <a:p>
+                      <a:r>
+                        <a:rPr sz="900">
+                          <a:solidFill>
+                            <a:srgbClr val="202020"/>
+                          </a:solidFill>
+                        </a:rPr>
+                        <a:t>233.2</a:t>
+                      </a:r>
+                    </a:p>
+                  </a:txBody>
+                  <a:tcPr marT="12700" marB="12700" marL="50800" marR="50800" anchor="ctr">
+                    <a:solidFill>
+                      <a:srgbClr val="F2F5F9"/>
+                    </a:solidFill>
+                  </a:tcPr>
+                </a:tc>
+                <a:tc>
+                  <a:txBody>
+                    <a:bodyPr/>
+                    <a:lstStyle/>
+                    <a:p>
+                      <a:r>
+                        <a:rPr sz="900">
+                          <a:solidFill>
+                            <a:srgbClr val="202020"/>
+                          </a:solidFill>
+                        </a:rPr>
+                        <a:t>85</a:t>
+                      </a:r>
+                    </a:p>
+                  </a:txBody>
+                  <a:tcPr marT="12700" marB="12700" marL="50800" marR="50800" anchor="ctr">
+                    <a:solidFill>
+                      <a:srgbClr val="F2F5F9"/>
+                    </a:solidFill>
+                  </a:tcPr>
+                </a:tc>
+              </a:tr>
+              <a:tr h="173736">
+                <a:tc>
+                  <a:txBody>
+                    <a:bodyPr/>
+                    <a:lstStyle/>
+                    <a:p>
+                      <a:r>
+                        <a:rPr sz="900">
+                          <a:solidFill>
+                            <a:srgbClr val="202020"/>
+                          </a:solidFill>
+                        </a:rPr>
+                        <a:t>Qwen3-32B</a:t>
+                      </a:r>
+                    </a:p>
+                  </a:txBody>
+                  <a:tcPr marT="12700" marB="12700" marL="50800" marR="50800" anchor="ctr">
+                    <a:solidFill>
+                      <a:srgbClr val="FFFFFF"/>
+                    </a:solidFill>
+                  </a:tcPr>
+                </a:tc>
+                <a:tc>
+                  <a:txBody>
+                    <a:bodyPr/>
+                    <a:lstStyle/>
+                    <a:p>
+                      <a:r>
+                        <a:rPr sz="900" b="1">
+                          <a:solidFill>
+                            <a:srgbClr val="7F7F7F"/>
+                          </a:solidFill>
+                        </a:rPr>
+                        <a:t>Baseline</a:t>
+                      </a:r>
+                    </a:p>
+                  </a:txBody>
+                  <a:tcPr marT="12700" marB="12700" marL="50800" marR="50800" anchor="ctr">
+                    <a:solidFill>
+                      <a:srgbClr val="FFFFFF"/>
+                    </a:solidFill>
+                  </a:tcPr>
+                </a:tc>
+                <a:tc>
+                  <a:txBody>
+                    <a:bodyPr/>
+                    <a:lstStyle/>
+                    <a:p>
+                      <a:r>
+                        <a:rPr sz="900">
+                          <a:solidFill>
+                            <a:srgbClr val="202020"/>
+                          </a:solidFill>
+                        </a:rPr>
+                        <a:t>32</a:t>
+                      </a:r>
+                    </a:p>
+                  </a:txBody>
+                  <a:tcPr marT="12700" marB="12700" marL="50800" marR="50800" anchor="ctr">
+                    <a:solidFill>
+                      <a:srgbClr val="FFFFFF"/>
+                    </a:solidFill>
+                  </a:tcPr>
+                </a:tc>
+                <a:tc>
+                  <a:txBody>
+                    <a:bodyPr/>
+                    <a:lstStyle/>
+                    <a:p>
+                      <a:r>
+                        <a:rPr sz="900">
+                          <a:solidFill>
+                            <a:srgbClr val="202020"/>
+                          </a:solidFill>
+                        </a:rPr>
+                        <a:t>1004</a:t>
+                      </a:r>
+                    </a:p>
+                  </a:txBody>
+                  <a:tcPr marT="12700" marB="12700" marL="50800" marR="50800" anchor="ctr">
+                    <a:solidFill>
+                      <a:srgbClr val="FFFFFF"/>
+                    </a:solidFill>
+                  </a:tcPr>
+                </a:tc>
+                <a:tc>
+                  <a:txBody>
+                    <a:bodyPr/>
+                    <a:lstStyle/>
+                    <a:p>
+                      <a:r>
+                        <a:rPr sz="900">
+                          <a:solidFill>
+                            <a:srgbClr val="202020"/>
+                          </a:solidFill>
+                        </a:rPr>
+                        <a:t>210.82</a:t>
+                      </a:r>
+                    </a:p>
+                  </a:txBody>
+                  <a:tcPr marT="12700" marB="12700" marL="50800" marR="50800" anchor="ctr">
+                    <a:solidFill>
+                      <a:srgbClr val="FFFFFF"/>
+                    </a:solidFill>
+                  </a:tcPr>
+                </a:tc>
+                <a:tc>
+                  <a:txBody>
+                    <a:bodyPr/>
+                    <a:lstStyle/>
+                    <a:p>
+                      <a:r>
+                        <a:rPr sz="900">
+                          <a:solidFill>
+                            <a:srgbClr val="202020"/>
+                          </a:solidFill>
+                        </a:rPr>
+                        <a:t>454.9</a:t>
+                      </a:r>
+                    </a:p>
+                  </a:txBody>
+                  <a:tcPr marT="12700" marB="12700" marL="50800" marR="50800" anchor="ctr">
+                    <a:solidFill>
+                      <a:srgbClr val="FFFFFF"/>
+                    </a:solidFill>
+                  </a:tcPr>
+                </a:tc>
+                <a:tc>
+                  <a:txBody>
+                    <a:bodyPr/>
+                    <a:lstStyle/>
+                    <a:p>
+                      <a:r>
+                        <a:rPr sz="900">
+                          <a:solidFill>
+                            <a:srgbClr val="202020"/>
+                          </a:solidFill>
+                        </a:rPr>
+                        <a:t>-</a:t>
+                      </a:r>
+                    </a:p>
+                  </a:txBody>
+                  <a:tcPr marT="12700" marB="12700" marL="50800" marR="50800" anchor="ctr">
+                    <a:solidFill>
+                      <a:srgbClr val="FFFFFF"/>
+                    </a:solidFill>
+                  </a:tcPr>
+                </a:tc>
+              </a:tr>
+              <a:tr h="173736">
+                <a:tc>
+                  <a:txBody>
+                    <a:bodyPr/>
+                    <a:lstStyle/>
+                    <a:p>
+                      <a:r>
+                        <a:rPr sz="900">
+                          <a:solidFill>
+                            <a:srgbClr val="202020"/>
+                          </a:solidFill>
+                        </a:rPr>
+                        <a:t/>
+                      </a:r>
+                    </a:p>
+                  </a:txBody>
+                  <a:tcPr marT="12700" marB="12700" marL="50800" marR="50800" anchor="ctr">
+                    <a:solidFill>
+                      <a:srgbClr val="FFFFFF"/>
+                    </a:solidFill>
+                  </a:tcPr>
+                </a:tc>
+                <a:tc>
+                  <a:txBody>
+                    <a:bodyPr/>
+                    <a:lstStyle/>
+                    <a:p>
+                      <a:r>
+                        <a:rPr sz="900" b="1">
+                          <a:solidFill>
+                            <a:srgbClr val="1F77B4"/>
+                          </a:solidFill>
+                        </a:rPr>
+                        <a:t>Native CPU offload</a:t>
+                      </a:r>
+                    </a:p>
+                  </a:txBody>
+                  <a:tcPr marT="12700" marB="12700" marL="50800" marR="50800" anchor="ctr">
+                    <a:solidFill>
+                      <a:srgbClr val="FFFFFF"/>
+                    </a:solidFill>
+                  </a:tcPr>
+                </a:tc>
+                <a:tc>
+                  <a:txBody>
+                    <a:bodyPr/>
+                    <a:lstStyle/>
+                    <a:p>
+                      <a:r>
+                        <a:rPr sz="900">
+                          <a:solidFill>
+                            <a:srgbClr val="202020"/>
+                          </a:solidFill>
+                        </a:rPr>
+                        <a:t>32</a:t>
+                      </a:r>
+                    </a:p>
+                  </a:txBody>
+                  <a:tcPr marT="12700" marB="12700" marL="50800" marR="50800" anchor="ctr">
+                    <a:solidFill>
+                      <a:srgbClr val="FFFFFF"/>
+                    </a:solidFill>
+                  </a:tcPr>
+                </a:tc>
+                <a:tc>
+                  <a:txBody>
+                    <a:bodyPr/>
+                    <a:lstStyle/>
+                    <a:p>
+                      <a:r>
+                        <a:rPr sz="900">
+                          <a:solidFill>
+                            <a:srgbClr val="202020"/>
+                          </a:solidFill>
+                        </a:rPr>
+                        <a:t>1117</a:t>
+                      </a:r>
+                    </a:p>
+                  </a:txBody>
+                  <a:tcPr marT="12700" marB="12700" marL="50800" marR="50800" anchor="ctr">
+                    <a:solidFill>
+                      <a:srgbClr val="FFFFFF"/>
+                    </a:solidFill>
+                  </a:tcPr>
+                </a:tc>
+                <a:tc>
+                  <a:txBody>
+                    <a:bodyPr/>
+                    <a:lstStyle/>
+                    <a:p>
+                      <a:r>
+                        <a:rPr sz="900">
+                          <a:solidFill>
+                            <a:srgbClr val="202020"/>
+                          </a:solidFill>
+                        </a:rPr>
+                        <a:t>190.62</a:t>
+                      </a:r>
+                    </a:p>
+                  </a:txBody>
+                  <a:tcPr marT="12700" marB="12700" marL="50800" marR="50800" anchor="ctr">
+                    <a:solidFill>
+                      <a:srgbClr val="FFFFFF"/>
+                    </a:solidFill>
+                  </a:tcPr>
+                </a:tc>
+                <a:tc>
+                  <a:txBody>
+                    <a:bodyPr/>
+                    <a:lstStyle/>
+                    <a:p>
+                      <a:r>
+                        <a:rPr sz="900">
+                          <a:solidFill>
+                            <a:srgbClr val="202020"/>
+                          </a:solidFill>
+                        </a:rPr>
+                        <a:t>405.7</a:t>
+                      </a:r>
+                    </a:p>
+                  </a:txBody>
+                  <a:tcPr marT="12700" marB="12700" marL="50800" marR="50800" anchor="ctr">
+                    <a:solidFill>
+                      <a:srgbClr val="FFFFFF"/>
+                    </a:solidFill>
+                  </a:tcPr>
+                </a:tc>
+                <a:tc>
+                  <a:txBody>
+                    <a:bodyPr/>
+                    <a:lstStyle/>
+                    <a:p>
+                      <a:r>
+                        <a:rPr sz="900">
+                          <a:solidFill>
+                            <a:srgbClr val="202020"/>
+                          </a:solidFill>
+                        </a:rPr>
+                        <a:t>33</a:t>
+                      </a:r>
+                    </a:p>
+                  </a:txBody>
+                  <a:tcPr marT="12700" marB="12700" marL="50800" marR="50800" anchor="ctr">
+                    <a:solidFill>
+                      <a:srgbClr val="FFFFFF"/>
+                    </a:solidFill>
+                  </a:tcPr>
+                </a:tc>
+              </a:tr>
+              <a:tr h="173736">
+                <a:tc>
+                  <a:txBody>
+                    <a:bodyPr/>
+                    <a:lstStyle/>
+                    <a:p>
+                      <a:r>
+                        <a:rPr sz="900">
+                          <a:solidFill>
+                            <a:srgbClr val="202020"/>
+                          </a:solidFill>
+                        </a:rPr>
+                        <a:t/>
+                      </a:r>
+                    </a:p>
+                  </a:txBody>
+                  <a:tcPr marT="12700" marB="12700" marL="50800" marR="50800" anchor="ctr">
+                    <a:solidFill>
+                      <a:srgbClr val="FFFFFF"/>
+                    </a:solidFill>
+                  </a:tcPr>
+                </a:tc>
+                <a:tc>
+                  <a:txBody>
+                    <a:bodyPr/>
+                    <a:lstStyle/>
+                    <a:p>
+                      <a:r>
+                        <a:rPr sz="900" b="1">
+                          <a:solidFill>
+                            <a:srgbClr val="2CA02C"/>
+                          </a:solidFill>
+                        </a:rPr>
+                        <a:t>Native FS offload</a:t>
+                      </a:r>
+                    </a:p>
+                  </a:txBody>
+                  <a:tcPr marT="12700" marB="12700" marL="50800" marR="50800" anchor="ctr">
+                    <a:solidFill>
+                      <a:srgbClr val="FFFFFF"/>
+                    </a:solidFill>
+                  </a:tcPr>
+                </a:tc>
+                <a:tc>
+                  <a:txBody>
+                    <a:bodyPr/>
+                    <a:lstStyle/>
+                    <a:p>
+                      <a:r>
+                        <a:rPr sz="900">
+                          <a:solidFill>
+                            <a:srgbClr val="202020"/>
+                          </a:solidFill>
+                        </a:rPr>
+                        <a:t>32</a:t>
+                      </a:r>
+                    </a:p>
+                  </a:txBody>
+                  <a:tcPr marT="12700" marB="12700" marL="50800" marR="50800" anchor="ctr">
+                    <a:solidFill>
+                      <a:srgbClr val="FFFFFF"/>
+                    </a:solidFill>
+                  </a:tcPr>
+                </a:tc>
+                <a:tc>
+                  <a:txBody>
+                    <a:bodyPr/>
+                    <a:lstStyle/>
+                    <a:p>
+                      <a:r>
+                        <a:rPr sz="900">
+                          <a:solidFill>
+                            <a:srgbClr val="202020"/>
+                          </a:solidFill>
+                        </a:rPr>
+                        <a:t>1506</a:t>
+                      </a:r>
+                    </a:p>
+                  </a:txBody>
+                  <a:tcPr marT="12700" marB="12700" marL="50800" marR="50800" anchor="ctr">
+                    <a:solidFill>
+                      <a:srgbClr val="FFFFFF"/>
+                    </a:solidFill>
+                  </a:tcPr>
+                </a:tc>
+                <a:tc>
+                  <a:txBody>
+                    <a:bodyPr/>
+                    <a:lstStyle/>
+                    <a:p>
+                      <a:r>
+                        <a:rPr sz="900">
+                          <a:solidFill>
+                            <a:srgbClr val="202020"/>
+                          </a:solidFill>
+                        </a:rPr>
+                        <a:t>114.84</a:t>
+                      </a:r>
+                    </a:p>
+                  </a:txBody>
+                  <a:tcPr marT="12700" marB="12700" marL="50800" marR="50800" anchor="ctr">
+                    <a:solidFill>
+                      <a:srgbClr val="FFFFFF"/>
+                    </a:solidFill>
+                  </a:tcPr>
+                </a:tc>
+                <a:tc>
+                  <a:txBody>
+                    <a:bodyPr/>
+                    <a:lstStyle/>
+                    <a:p>
+                      <a:r>
+                        <a:rPr sz="900">
+                          <a:solidFill>
+                            <a:srgbClr val="202020"/>
+                          </a:solidFill>
+                        </a:rPr>
+                        <a:t>322.2</a:t>
+                      </a:r>
+                    </a:p>
+                  </a:txBody>
+                  <a:tcPr marT="12700" marB="12700" marL="50800" marR="50800" anchor="ctr">
+                    <a:solidFill>
+                      <a:srgbClr val="FFFFFF"/>
+                    </a:solidFill>
+                  </a:tcPr>
+                </a:tc>
+                <a:tc>
+                  <a:txBody>
+                    <a:bodyPr/>
+                    <a:lstStyle/>
+                    <a:p>
+                      <a:r>
+                        <a:rPr sz="900">
+                          <a:solidFill>
+                            <a:srgbClr val="202020"/>
+                          </a:solidFill>
+                        </a:rPr>
+                        <a:t>87</a:t>
+                      </a:r>
+                    </a:p>
+                  </a:txBody>
+                  <a:tcPr marT="12700" marB="12700" marL="50800" marR="50800" anchor="ctr">
+                    <a:solidFill>
+                      <a:srgbClr val="FFFFFF"/>
+                    </a:solidFill>
+                  </a:tcPr>
+                </a:tc>
+              </a:tr>
+            </a:tbl>
+          </a:graphicData>
+        </a:graphic>
+      </p:graphicFrame>
     </p:spTree>
   </p:cSld>
   <p:clrMapOvr>

</xml_diff>